<commit_message>
fix: Move detail pages back to pages/, fix all broken links, 116/116 tests pass
- Moved 29 detail pages from pages/_detail/ back to pages/ (Streamlit
  doesn't support page_link to subdirectories)
- Fixed all pages/_detail/ references to pages/ across 8 files
- Fixed broken link: 13_Client_Presentation.py → 13_Document_Hub.py
- Added full_system_test.py — comprehensive 116-point test suite
- ALL tests pass: syntax (82), imports (11), links (0 broken),
  config (46/46), database (15 tables), calculations (21/21),
  documents (DOCX+PPTX+XLSX+PDF), drawings (162), APIs (3/3),
  self-healing (100%), agro (6 crops), presenter (15 slides + AI copilot)

Co-Authored-By: Claude Opus 4.6 (1M context) <noreply@anthropic.com>
</commit_message>
<xml_diff>
--- a/data/auto_synced/Investor_Pitch_30MT_Uttar_Pradesh.pptx
+++ b/data/auto_synced/Investor_Pitch_30MT_Uttar_Pradesh.pptx
@@ -3137,7 +3137,7 @@
           </a:p>
           <a:p>
             <a:r>
-              <a:t>Investment: Rs 12.00 Crore | IRR: 34.3%</a:t>
+              <a:t>Investment: Rs 12.00 Crore | IRR: 32.2%</a:t>
             </a:r>
           </a:p>
           <a:p>
@@ -3297,22 +3297,22 @@
           </a:p>
           <a:p>
             <a:r>
-              <a:t>• Annual Revenue (Yr5): Rs 1273 Lakhs</a:t>
-            </a:r>
-          </a:p>
-          <a:p>
-            <a:r>
-              <a:t>• ROI: 21.9% | IRR: 34.3%</a:t>
-            </a:r>
-          </a:p>
-          <a:p>
-            <a:r>
-              <a:t>• Break-Even: 52 months</a:t>
-            </a:r>
-          </a:p>
-          <a:p>
-            <a:r>
-              <a:t>• DSCR: 2.01x</a:t>
+              <a:t>• Annual Revenue (Yr5): Rs 1232 Lakhs</a:t>
+            </a:r>
+          </a:p>
+          <a:p>
+            <a:r>
+              <a:t>• ROI: 20.7% | IRR: 32.2%</a:t>
+            </a:r>
+          </a:p>
+          <a:p>
+            <a:r>
+              <a:t>• Break-Even: 54 months</a:t>
+            </a:r>
+          </a:p>
+          <a:p>
+            <a:r>
+              <a:t>• DSCR: 1.93x</a:t>
             </a:r>
           </a:p>
         </p:txBody>
@@ -3547,27 +3547,27 @@
           </a:p>
           <a:p>
             <a:r>
-              <a:t>Yr1 | Rs 599L | Rs 231L | Rs 21L | 0.94x</a:t>
-            </a:r>
-          </a:p>
-          <a:p>
-            <a:r>
-              <a:t>Yr2 | Rs 824L | Rs 338L | Rs 101L | 1.47x</a:t>
-            </a:r>
-          </a:p>
-          <a:p>
-            <a:r>
-              <a:t>Yr3 | Rs 1048L | Rs 445L | Rs 182L | 2.01x</a:t>
-            </a:r>
-          </a:p>
-          <a:p>
-            <a:r>
-              <a:t>Yr4 | Rs 1198L | Rs 517L | Rs 236L | 2.37x</a:t>
-            </a:r>
-          </a:p>
-          <a:p>
-            <a:r>
-              <a:t>Yr5 | Rs 1273L | Rs 553L | Rs 263L | 2.55x</a:t>
+              <a:t>Yr1 | Rs 580L | Rs 221L | Rs 14L | 0.89x</a:t>
+            </a:r>
+          </a:p>
+          <a:p>
+            <a:r>
+              <a:t>Yr2 | Rs 797L | Rs 325L | Rs 92L | 1.41x</a:t>
+            </a:r>
+          </a:p>
+          <a:p>
+            <a:r>
+              <a:t>Yr3 | Rs 1014L | Rs 429L | Rs 170L | 1.93x</a:t>
+            </a:r>
+          </a:p>
+          <a:p>
+            <a:r>
+              <a:t>Yr4 | Rs 1159L | Rs 499L | Rs 222L | 2.28x</a:t>
+            </a:r>
+          </a:p>
+          <a:p>
+            <a:r>
+              <a:t>Yr5 | Rs 1232L | Rs 533L | Rs 248L | 2.45x</a:t>
             </a:r>
           </a:p>
           <a:p/>
@@ -3643,12 +3643,12 @@
           </a:p>
           <a:p>
             <a:r>
-              <a:t>• Expected equity IRR: 34.3%</a:t>
-            </a:r>
-          </a:p>
-          <a:p>
-            <a:r>
-              <a:t>• Payback period: 52 months</a:t>
+              <a:t>• Expected equity IRR: 32.2%</a:t>
+            </a:r>
+          </a:p>
+          <a:p>
+            <a:r>
+              <a:t>• Payback period: 54 months</a:t>
             </a:r>
           </a:p>
         </p:txBody>

</xml_diff>